<commit_message>
updates through lecture 17
</commit_message>
<xml_diff>
--- a/Lecture_Slides/PH 123 Lecture 10.pptx
+++ b/Lecture_Slides/PH 123 Lecture 10.pptx
@@ -146,7 +146,7 @@
 <file path=ppt/revisionInfo.xml><?xml version="1.0" encoding="utf-8"?>
 <p1510:revInfo xmlns:a="http://schemas.openxmlformats.org/drawingml/2006/main" xmlns:r="http://schemas.openxmlformats.org/officeDocument/2006/relationships" xmlns:p1510="http://schemas.microsoft.com/office/powerpoint/2015/10/main">
   <p1510:revLst>
-    <p1510:client id="{617507A3-B23C-4814-86A3-AA497BF70DCA}" v="3" dt="2025-05-07T15:37:28.390"/>
+    <p1510:client id="{DB0D29AF-5E8F-4900-AE90-84F19B618C67}" v="1" dt="2026-05-05T16:26:58.431"/>
   </p1510:revLst>
 </p1510:revInfo>
 </file>
@@ -154,380 +154,34 @@
 <file path=ppt/changesInfos/changesInfo1.xml><?xml version="1.0" encoding="utf-8"?>
 <pc:chgInfo xmlns:a="http://schemas.openxmlformats.org/drawingml/2006/main" xmlns:r="http://schemas.openxmlformats.org/officeDocument/2006/relationships" xmlns:ac="http://schemas.microsoft.com/office/drawing/2013/main/command" xmlns:pc="http://schemas.microsoft.com/office/powerpoint/2013/main/command">
   <pc:docChgLst>
-    <pc:chgData name="Lines, Todd" userId="afaf7c3a-e8aa-4568-882a-02ad8f9e19b0" providerId="ADAL" clId="{617507A3-B23C-4814-86A3-AA497BF70DCA}"/>
-    <pc:docChg chg="custSel addSld delSld modSld sldOrd">
-      <pc:chgData name="Lines, Todd" userId="afaf7c3a-e8aa-4568-882a-02ad8f9e19b0" providerId="ADAL" clId="{617507A3-B23C-4814-86A3-AA497BF70DCA}" dt="2025-05-07T15:37:28.389" v="22"/>
+    <pc:chgData name="Lines, Todd" userId="afaf7c3a-e8aa-4568-882a-02ad8f9e19b0" providerId="ADAL" clId="{5FF5AC1B-ABA9-43D7-A1E3-2D92732CD6E2}"/>
+    <pc:docChg chg="custSel modSld">
+      <pc:chgData name="Lines, Todd" userId="afaf7c3a-e8aa-4568-882a-02ad8f9e19b0" providerId="ADAL" clId="{5FF5AC1B-ABA9-43D7-A1E3-2D92732CD6E2}" dt="2026-05-05T16:27:02.472" v="4" actId="21"/>
       <pc:docMkLst>
         <pc:docMk/>
       </pc:docMkLst>
-      <pc:sldChg chg="add">
-        <pc:chgData name="Lines, Todd" userId="afaf7c3a-e8aa-4568-882a-02ad8f9e19b0" providerId="ADAL" clId="{617507A3-B23C-4814-86A3-AA497BF70DCA}" dt="2025-04-30T21:18:26.062" v="17"/>
-        <pc:sldMkLst>
-          <pc:docMk/>
-          <pc:sldMk cId="0" sldId="267"/>
-        </pc:sldMkLst>
-      </pc:sldChg>
-      <pc:sldChg chg="add">
-        <pc:chgData name="Lines, Todd" userId="afaf7c3a-e8aa-4568-882a-02ad8f9e19b0" providerId="ADAL" clId="{617507A3-B23C-4814-86A3-AA497BF70DCA}" dt="2025-04-30T21:18:26.062" v="17"/>
-        <pc:sldMkLst>
-          <pc:docMk/>
-          <pc:sldMk cId="0" sldId="268"/>
-        </pc:sldMkLst>
-      </pc:sldChg>
-      <pc:sldChg chg="del">
-        <pc:chgData name="Lines, Todd" userId="afaf7c3a-e8aa-4568-882a-02ad8f9e19b0" providerId="ADAL" clId="{617507A3-B23C-4814-86A3-AA497BF70DCA}" dt="2025-04-30T21:23:16.841" v="19" actId="47"/>
-        <pc:sldMkLst>
-          <pc:docMk/>
-          <pc:sldMk cId="0" sldId="269"/>
-        </pc:sldMkLst>
-      </pc:sldChg>
-      <pc:sldChg chg="del">
-        <pc:chgData name="Lines, Todd" userId="afaf7c3a-e8aa-4568-882a-02ad8f9e19b0" providerId="ADAL" clId="{617507A3-B23C-4814-86A3-AA497BF70DCA}" dt="2025-04-30T21:23:16.841" v="19" actId="47"/>
-        <pc:sldMkLst>
-          <pc:docMk/>
-          <pc:sldMk cId="0" sldId="270"/>
-        </pc:sldMkLst>
-      </pc:sldChg>
-      <pc:sldChg chg="del">
-        <pc:chgData name="Lines, Todd" userId="afaf7c3a-e8aa-4568-882a-02ad8f9e19b0" providerId="ADAL" clId="{617507A3-B23C-4814-86A3-AA497BF70DCA}" dt="2025-04-30T21:23:16.841" v="19" actId="47"/>
-        <pc:sldMkLst>
-          <pc:docMk/>
-          <pc:sldMk cId="0" sldId="271"/>
-        </pc:sldMkLst>
-      </pc:sldChg>
-      <pc:sldChg chg="del">
-        <pc:chgData name="Lines, Todd" userId="afaf7c3a-e8aa-4568-882a-02ad8f9e19b0" providerId="ADAL" clId="{617507A3-B23C-4814-86A3-AA497BF70DCA}" dt="2025-04-30T21:23:16.841" v="19" actId="47"/>
-        <pc:sldMkLst>
-          <pc:docMk/>
-          <pc:sldMk cId="0" sldId="272"/>
-        </pc:sldMkLst>
-      </pc:sldChg>
-      <pc:sldChg chg="del">
-        <pc:chgData name="Lines, Todd" userId="afaf7c3a-e8aa-4568-882a-02ad8f9e19b0" providerId="ADAL" clId="{617507A3-B23C-4814-86A3-AA497BF70DCA}" dt="2025-04-30T21:23:16.841" v="19" actId="47"/>
-        <pc:sldMkLst>
-          <pc:docMk/>
-          <pc:sldMk cId="0" sldId="273"/>
-        </pc:sldMkLst>
-      </pc:sldChg>
-      <pc:sldChg chg="del">
-        <pc:chgData name="Lines, Todd" userId="afaf7c3a-e8aa-4568-882a-02ad8f9e19b0" providerId="ADAL" clId="{617507A3-B23C-4814-86A3-AA497BF70DCA}" dt="2025-04-30T21:23:16.841" v="19" actId="47"/>
-        <pc:sldMkLst>
-          <pc:docMk/>
-          <pc:sldMk cId="0" sldId="274"/>
-        </pc:sldMkLst>
-      </pc:sldChg>
-      <pc:sldChg chg="del">
-        <pc:chgData name="Lines, Todd" userId="afaf7c3a-e8aa-4568-882a-02ad8f9e19b0" providerId="ADAL" clId="{617507A3-B23C-4814-86A3-AA497BF70DCA}" dt="2025-04-30T21:23:16.841" v="19" actId="47"/>
-        <pc:sldMkLst>
-          <pc:docMk/>
-          <pc:sldMk cId="0" sldId="275"/>
-        </pc:sldMkLst>
-      </pc:sldChg>
-      <pc:sldChg chg="del">
-        <pc:chgData name="Lines, Todd" userId="afaf7c3a-e8aa-4568-882a-02ad8f9e19b0" providerId="ADAL" clId="{617507A3-B23C-4814-86A3-AA497BF70DCA}" dt="2025-04-30T21:23:16.841" v="19" actId="47"/>
-        <pc:sldMkLst>
-          <pc:docMk/>
-          <pc:sldMk cId="0" sldId="276"/>
-        </pc:sldMkLst>
-      </pc:sldChg>
-      <pc:sldChg chg="del">
-        <pc:chgData name="Lines, Todd" userId="afaf7c3a-e8aa-4568-882a-02ad8f9e19b0" providerId="ADAL" clId="{617507A3-B23C-4814-86A3-AA497BF70DCA}" dt="2025-04-30T21:23:16.841" v="19" actId="47"/>
-        <pc:sldMkLst>
-          <pc:docMk/>
-          <pc:sldMk cId="0" sldId="277"/>
-        </pc:sldMkLst>
-      </pc:sldChg>
-      <pc:sldChg chg="del">
-        <pc:chgData name="Lines, Todd" userId="afaf7c3a-e8aa-4568-882a-02ad8f9e19b0" providerId="ADAL" clId="{617507A3-B23C-4814-86A3-AA497BF70DCA}" dt="2025-04-30T21:23:16.841" v="19" actId="47"/>
-        <pc:sldMkLst>
-          <pc:docMk/>
-          <pc:sldMk cId="0" sldId="278"/>
-        </pc:sldMkLst>
-      </pc:sldChg>
-      <pc:sldChg chg="del">
-        <pc:chgData name="Lines, Todd" userId="afaf7c3a-e8aa-4568-882a-02ad8f9e19b0" providerId="ADAL" clId="{617507A3-B23C-4814-86A3-AA497BF70DCA}" dt="2025-04-30T21:23:16.841" v="19" actId="47"/>
-        <pc:sldMkLst>
-          <pc:docMk/>
-          <pc:sldMk cId="0" sldId="279"/>
-        </pc:sldMkLst>
-      </pc:sldChg>
-      <pc:sldChg chg="del">
-        <pc:chgData name="Lines, Todd" userId="afaf7c3a-e8aa-4568-882a-02ad8f9e19b0" providerId="ADAL" clId="{617507A3-B23C-4814-86A3-AA497BF70DCA}" dt="2025-04-30T21:23:16.841" v="19" actId="47"/>
-        <pc:sldMkLst>
-          <pc:docMk/>
-          <pc:sldMk cId="0" sldId="280"/>
-        </pc:sldMkLst>
-      </pc:sldChg>
-      <pc:sldChg chg="del">
-        <pc:chgData name="Lines, Todd" userId="afaf7c3a-e8aa-4568-882a-02ad8f9e19b0" providerId="ADAL" clId="{617507A3-B23C-4814-86A3-AA497BF70DCA}" dt="2025-04-30T21:23:16.841" v="19" actId="47"/>
-        <pc:sldMkLst>
-          <pc:docMk/>
-          <pc:sldMk cId="0" sldId="281"/>
-        </pc:sldMkLst>
-      </pc:sldChg>
-      <pc:sldChg chg="del">
-        <pc:chgData name="Lines, Todd" userId="afaf7c3a-e8aa-4568-882a-02ad8f9e19b0" providerId="ADAL" clId="{617507A3-B23C-4814-86A3-AA497BF70DCA}" dt="2025-04-30T21:23:16.841" v="19" actId="47"/>
-        <pc:sldMkLst>
-          <pc:docMk/>
-          <pc:sldMk cId="0" sldId="282"/>
-        </pc:sldMkLst>
-      </pc:sldChg>
-      <pc:sldChg chg="del">
-        <pc:chgData name="Lines, Todd" userId="afaf7c3a-e8aa-4568-882a-02ad8f9e19b0" providerId="ADAL" clId="{617507A3-B23C-4814-86A3-AA497BF70DCA}" dt="2025-04-30T21:23:16.841" v="19" actId="47"/>
-        <pc:sldMkLst>
-          <pc:docMk/>
-          <pc:sldMk cId="0" sldId="283"/>
-        </pc:sldMkLst>
-      </pc:sldChg>
-      <pc:sldChg chg="del">
-        <pc:chgData name="Lines, Todd" userId="afaf7c3a-e8aa-4568-882a-02ad8f9e19b0" providerId="ADAL" clId="{617507A3-B23C-4814-86A3-AA497BF70DCA}" dt="2025-04-30T21:23:16.841" v="19" actId="47"/>
-        <pc:sldMkLst>
-          <pc:docMk/>
-          <pc:sldMk cId="0" sldId="284"/>
-        </pc:sldMkLst>
-      </pc:sldChg>
-      <pc:sldChg chg="del">
-        <pc:chgData name="Lines, Todd" userId="afaf7c3a-e8aa-4568-882a-02ad8f9e19b0" providerId="ADAL" clId="{617507A3-B23C-4814-86A3-AA497BF70DCA}" dt="2025-04-30T21:23:16.841" v="19" actId="47"/>
-        <pc:sldMkLst>
-          <pc:docMk/>
-          <pc:sldMk cId="0" sldId="285"/>
-        </pc:sldMkLst>
-      </pc:sldChg>
-      <pc:sldChg chg="del">
-        <pc:chgData name="Lines, Todd" userId="afaf7c3a-e8aa-4568-882a-02ad8f9e19b0" providerId="ADAL" clId="{617507A3-B23C-4814-86A3-AA497BF70DCA}" dt="2025-04-30T21:23:16.841" v="19" actId="47"/>
-        <pc:sldMkLst>
-          <pc:docMk/>
-          <pc:sldMk cId="0" sldId="286"/>
-        </pc:sldMkLst>
-      </pc:sldChg>
-      <pc:sldChg chg="del">
-        <pc:chgData name="Lines, Todd" userId="afaf7c3a-e8aa-4568-882a-02ad8f9e19b0" providerId="ADAL" clId="{617507A3-B23C-4814-86A3-AA497BF70DCA}" dt="2025-04-30T21:23:16.841" v="19" actId="47"/>
-        <pc:sldMkLst>
-          <pc:docMk/>
-          <pc:sldMk cId="0" sldId="287"/>
-        </pc:sldMkLst>
-      </pc:sldChg>
-      <pc:sldChg chg="del">
-        <pc:chgData name="Lines, Todd" userId="afaf7c3a-e8aa-4568-882a-02ad8f9e19b0" providerId="ADAL" clId="{617507A3-B23C-4814-86A3-AA497BF70DCA}" dt="2025-04-30T21:23:16.841" v="19" actId="47"/>
-        <pc:sldMkLst>
-          <pc:docMk/>
-          <pc:sldMk cId="0" sldId="288"/>
-        </pc:sldMkLst>
-      </pc:sldChg>
-      <pc:sldChg chg="del">
-        <pc:chgData name="Lines, Todd" userId="afaf7c3a-e8aa-4568-882a-02ad8f9e19b0" providerId="ADAL" clId="{617507A3-B23C-4814-86A3-AA497BF70DCA}" dt="2025-04-30T21:23:16.841" v="19" actId="47"/>
-        <pc:sldMkLst>
-          <pc:docMk/>
-          <pc:sldMk cId="0" sldId="289"/>
-        </pc:sldMkLst>
-      </pc:sldChg>
-      <pc:sldChg chg="del">
-        <pc:chgData name="Lines, Todd" userId="afaf7c3a-e8aa-4568-882a-02ad8f9e19b0" providerId="ADAL" clId="{617507A3-B23C-4814-86A3-AA497BF70DCA}" dt="2025-04-30T21:23:16.841" v="19" actId="47"/>
-        <pc:sldMkLst>
-          <pc:docMk/>
-          <pc:sldMk cId="0" sldId="290"/>
-        </pc:sldMkLst>
-      </pc:sldChg>
-      <pc:sldChg chg="del">
-        <pc:chgData name="Lines, Todd" userId="afaf7c3a-e8aa-4568-882a-02ad8f9e19b0" providerId="ADAL" clId="{617507A3-B23C-4814-86A3-AA497BF70DCA}" dt="2025-04-30T21:23:16.841" v="19" actId="47"/>
-        <pc:sldMkLst>
-          <pc:docMk/>
-          <pc:sldMk cId="0" sldId="291"/>
-        </pc:sldMkLst>
-      </pc:sldChg>
-      <pc:sldChg chg="del">
-        <pc:chgData name="Lines, Todd" userId="afaf7c3a-e8aa-4568-882a-02ad8f9e19b0" providerId="ADAL" clId="{617507A3-B23C-4814-86A3-AA497BF70DCA}" dt="2025-04-30T21:23:16.841" v="19" actId="47"/>
-        <pc:sldMkLst>
-          <pc:docMk/>
-          <pc:sldMk cId="0" sldId="292"/>
-        </pc:sldMkLst>
-      </pc:sldChg>
-      <pc:sldChg chg="modSp new mod">
-        <pc:chgData name="Lines, Todd" userId="afaf7c3a-e8aa-4568-882a-02ad8f9e19b0" providerId="ADAL" clId="{617507A3-B23C-4814-86A3-AA497BF70DCA}" dt="2025-04-30T21:14:15.229" v="10" actId="20577"/>
-        <pc:sldMkLst>
-          <pc:docMk/>
-          <pc:sldMk cId="2630690811" sldId="293"/>
-        </pc:sldMkLst>
-        <pc:spChg chg="mod">
-          <ac:chgData name="Lines, Todd" userId="afaf7c3a-e8aa-4568-882a-02ad8f9e19b0" providerId="ADAL" clId="{617507A3-B23C-4814-86A3-AA497BF70DCA}" dt="2025-04-30T21:14:15.229" v="10" actId="20577"/>
-          <ac:spMkLst>
-            <pc:docMk/>
-            <pc:sldMk cId="2630690811" sldId="293"/>
-            <ac:spMk id="2" creationId="{48677102-2D8F-05F0-C316-945DA29AB7BC}"/>
-          </ac:spMkLst>
-        </pc:spChg>
-      </pc:sldChg>
-      <pc:sldChg chg="addSp delSp modSp new mod modClrScheme chgLayout">
-        <pc:chgData name="Lines, Todd" userId="afaf7c3a-e8aa-4568-882a-02ad8f9e19b0" providerId="ADAL" clId="{617507A3-B23C-4814-86A3-AA497BF70DCA}" dt="2025-04-30T21:14:23.337" v="15" actId="20577"/>
-        <pc:sldMkLst>
-          <pc:docMk/>
-          <pc:sldMk cId="665056197" sldId="294"/>
-        </pc:sldMkLst>
-        <pc:spChg chg="add mod ord">
-          <ac:chgData name="Lines, Todd" userId="afaf7c3a-e8aa-4568-882a-02ad8f9e19b0" providerId="ADAL" clId="{617507A3-B23C-4814-86A3-AA497BF70DCA}" dt="2025-04-30T21:14:23.337" v="15" actId="20577"/>
-          <ac:spMkLst>
-            <pc:docMk/>
-            <pc:sldMk cId="665056197" sldId="294"/>
-            <ac:spMk id="4" creationId="{E81D2D3B-F41E-C06A-1F2D-426F9E65B3A1}"/>
-          </ac:spMkLst>
-        </pc:spChg>
-        <pc:spChg chg="add mod ord">
-          <ac:chgData name="Lines, Todd" userId="afaf7c3a-e8aa-4568-882a-02ad8f9e19b0" providerId="ADAL" clId="{617507A3-B23C-4814-86A3-AA497BF70DCA}" dt="2025-04-30T21:14:20.934" v="12" actId="700"/>
-          <ac:spMkLst>
-            <pc:docMk/>
-            <pc:sldMk cId="665056197" sldId="294"/>
-            <ac:spMk id="5" creationId="{D75CFEB2-8707-0CD2-0E57-CE8294094BBB}"/>
-          </ac:spMkLst>
-        </pc:spChg>
-      </pc:sldChg>
-      <pc:sldChg chg="add">
-        <pc:chgData name="Lines, Todd" userId="afaf7c3a-e8aa-4568-882a-02ad8f9e19b0" providerId="ADAL" clId="{617507A3-B23C-4814-86A3-AA497BF70DCA}" dt="2025-04-30T21:16:33.815" v="16"/>
-        <pc:sldMkLst>
-          <pc:docMk/>
-          <pc:sldMk cId="3161209317" sldId="298"/>
-        </pc:sldMkLst>
-      </pc:sldChg>
-      <pc:sldChg chg="add">
-        <pc:chgData name="Lines, Todd" userId="afaf7c3a-e8aa-4568-882a-02ad8f9e19b0" providerId="ADAL" clId="{617507A3-B23C-4814-86A3-AA497BF70DCA}" dt="2025-04-30T21:16:33.815" v="16"/>
-        <pc:sldMkLst>
-          <pc:docMk/>
-          <pc:sldMk cId="3674213391" sldId="299"/>
-        </pc:sldMkLst>
-      </pc:sldChg>
-      <pc:sldChg chg="add">
-        <pc:chgData name="Lines, Todd" userId="afaf7c3a-e8aa-4568-882a-02ad8f9e19b0" providerId="ADAL" clId="{617507A3-B23C-4814-86A3-AA497BF70DCA}" dt="2025-04-30T21:16:33.815" v="16"/>
-        <pc:sldMkLst>
-          <pc:docMk/>
-          <pc:sldMk cId="2918768208" sldId="300"/>
-        </pc:sldMkLst>
-      </pc:sldChg>
-      <pc:sldChg chg="add ord">
-        <pc:chgData name="Lines, Todd" userId="afaf7c3a-e8aa-4568-882a-02ad8f9e19b0" providerId="ADAL" clId="{617507A3-B23C-4814-86A3-AA497BF70DCA}" dt="2025-05-06T22:10:06.831" v="21"/>
-        <pc:sldMkLst>
-          <pc:docMk/>
-          <pc:sldMk cId="2700378708" sldId="301"/>
-        </pc:sldMkLst>
-      </pc:sldChg>
-      <pc:sldChg chg="add">
-        <pc:chgData name="Lines, Todd" userId="afaf7c3a-e8aa-4568-882a-02ad8f9e19b0" providerId="ADAL" clId="{617507A3-B23C-4814-86A3-AA497BF70DCA}" dt="2025-04-30T21:16:33.815" v="16"/>
-        <pc:sldMkLst>
-          <pc:docMk/>
-          <pc:sldMk cId="4011188011" sldId="302"/>
-        </pc:sldMkLst>
-      </pc:sldChg>
-      <pc:sldChg chg="add">
-        <pc:chgData name="Lines, Todd" userId="afaf7c3a-e8aa-4568-882a-02ad8f9e19b0" providerId="ADAL" clId="{617507A3-B23C-4814-86A3-AA497BF70DCA}" dt="2025-04-30T21:16:33.815" v="16"/>
+      <pc:sldChg chg="delSp modSp mod">
+        <pc:chgData name="Lines, Todd" userId="afaf7c3a-e8aa-4568-882a-02ad8f9e19b0" providerId="ADAL" clId="{5FF5AC1B-ABA9-43D7-A1E3-2D92732CD6E2}" dt="2026-05-05T16:27:02.472" v="4" actId="21"/>
         <pc:sldMkLst>
           <pc:docMk/>
           <pc:sldMk cId="1222242176" sldId="314"/>
         </pc:sldMkLst>
-      </pc:sldChg>
-      <pc:sldChg chg="add">
-        <pc:chgData name="Lines, Todd" userId="afaf7c3a-e8aa-4568-882a-02ad8f9e19b0" providerId="ADAL" clId="{617507A3-B23C-4814-86A3-AA497BF70DCA}" dt="2025-04-30T21:16:33.815" v="16"/>
-        <pc:sldMkLst>
-          <pc:docMk/>
-          <pc:sldMk cId="1189374261" sldId="315"/>
-        </pc:sldMkLst>
-      </pc:sldChg>
-      <pc:sldChg chg="add">
-        <pc:chgData name="Lines, Todd" userId="afaf7c3a-e8aa-4568-882a-02ad8f9e19b0" providerId="ADAL" clId="{617507A3-B23C-4814-86A3-AA497BF70DCA}" dt="2025-04-30T21:16:33.815" v="16"/>
-        <pc:sldMkLst>
-          <pc:docMk/>
-          <pc:sldMk cId="1734463390" sldId="316"/>
-        </pc:sldMkLst>
-      </pc:sldChg>
-      <pc:sldChg chg="add">
-        <pc:chgData name="Lines, Todd" userId="afaf7c3a-e8aa-4568-882a-02ad8f9e19b0" providerId="ADAL" clId="{617507A3-B23C-4814-86A3-AA497BF70DCA}" dt="2025-04-30T21:16:33.815" v="16"/>
-        <pc:sldMkLst>
-          <pc:docMk/>
-          <pc:sldMk cId="3937303269" sldId="317"/>
-        </pc:sldMkLst>
-      </pc:sldChg>
-      <pc:sldChg chg="add del">
-        <pc:chgData name="Lines, Todd" userId="afaf7c3a-e8aa-4568-882a-02ad8f9e19b0" providerId="ADAL" clId="{617507A3-B23C-4814-86A3-AA497BF70DCA}" dt="2025-04-30T21:20:03.992" v="18" actId="2696"/>
-        <pc:sldMkLst>
-          <pc:docMk/>
-          <pc:sldMk cId="3726261940" sldId="336"/>
-        </pc:sldMkLst>
-      </pc:sldChg>
-      <pc:sldChg chg="add del">
-        <pc:chgData name="Lines, Todd" userId="afaf7c3a-e8aa-4568-882a-02ad8f9e19b0" providerId="ADAL" clId="{617507A3-B23C-4814-86A3-AA497BF70DCA}" dt="2025-04-30T21:20:03.992" v="18" actId="2696"/>
-        <pc:sldMkLst>
-          <pc:docMk/>
-          <pc:sldMk cId="3586236915" sldId="337"/>
-        </pc:sldMkLst>
-      </pc:sldChg>
-      <pc:sldChg chg="add">
-        <pc:chgData name="Lines, Todd" userId="afaf7c3a-e8aa-4568-882a-02ad8f9e19b0" providerId="ADAL" clId="{617507A3-B23C-4814-86A3-AA497BF70DCA}" dt="2025-04-30T21:16:33.815" v="16"/>
-        <pc:sldMkLst>
-          <pc:docMk/>
-          <pc:sldMk cId="1431144323" sldId="339"/>
-        </pc:sldMkLst>
-      </pc:sldChg>
-      <pc:sldChg chg="add">
-        <pc:chgData name="Lines, Todd" userId="afaf7c3a-e8aa-4568-882a-02ad8f9e19b0" providerId="ADAL" clId="{617507A3-B23C-4814-86A3-AA497BF70DCA}" dt="2025-04-30T21:16:33.815" v="16"/>
-        <pc:sldMkLst>
-          <pc:docMk/>
-          <pc:sldMk cId="3223561803" sldId="340"/>
-        </pc:sldMkLst>
-      </pc:sldChg>
-      <pc:sldChg chg="add del">
-        <pc:chgData name="Lines, Todd" userId="afaf7c3a-e8aa-4568-882a-02ad8f9e19b0" providerId="ADAL" clId="{617507A3-B23C-4814-86A3-AA497BF70DCA}" dt="2025-04-30T21:20:03.992" v="18" actId="2696"/>
-        <pc:sldMkLst>
-          <pc:docMk/>
-          <pc:sldMk cId="1378880535" sldId="342"/>
-        </pc:sldMkLst>
-      </pc:sldChg>
-      <pc:sldChg chg="add del">
-        <pc:chgData name="Lines, Todd" userId="afaf7c3a-e8aa-4568-882a-02ad8f9e19b0" providerId="ADAL" clId="{617507A3-B23C-4814-86A3-AA497BF70DCA}" dt="2025-04-30T21:20:03.992" v="18" actId="2696"/>
-        <pc:sldMkLst>
-          <pc:docMk/>
-          <pc:sldMk cId="2432453708" sldId="343"/>
-        </pc:sldMkLst>
-      </pc:sldChg>
-      <pc:sldChg chg="add">
-        <pc:chgData name="Lines, Todd" userId="afaf7c3a-e8aa-4568-882a-02ad8f9e19b0" providerId="ADAL" clId="{617507A3-B23C-4814-86A3-AA497BF70DCA}" dt="2025-04-30T21:18:26.062" v="17"/>
-        <pc:sldMkLst>
-          <pc:docMk/>
-          <pc:sldMk cId="4224129433" sldId="344"/>
-        </pc:sldMkLst>
-      </pc:sldChg>
-      <pc:sldChg chg="add">
-        <pc:chgData name="Lines, Todd" userId="afaf7c3a-e8aa-4568-882a-02ad8f9e19b0" providerId="ADAL" clId="{617507A3-B23C-4814-86A3-AA497BF70DCA}" dt="2025-04-30T21:18:26.062" v="17"/>
-        <pc:sldMkLst>
-          <pc:docMk/>
-          <pc:sldMk cId="1763055361" sldId="345"/>
-        </pc:sldMkLst>
-      </pc:sldChg>
-      <pc:sldChg chg="add">
-        <pc:chgData name="Lines, Todd" userId="afaf7c3a-e8aa-4568-882a-02ad8f9e19b0" providerId="ADAL" clId="{617507A3-B23C-4814-86A3-AA497BF70DCA}" dt="2025-05-07T15:37:28.389" v="22"/>
-        <pc:sldMkLst>
-          <pc:docMk/>
-          <pc:sldMk cId="761006191" sldId="1456"/>
-        </pc:sldMkLst>
-      </pc:sldChg>
-    </pc:docChg>
-  </pc:docChgLst>
-  <pc:docChgLst>
-    <pc:chgData name="Lines, Todd" userId="afaf7c3a-e8aa-4568-882a-02ad8f9e19b0" providerId="ADAL" clId="{298A166D-7D97-431D-8FAB-198A4D7160F4}"/>
-    <pc:docChg chg="modSld">
-      <pc:chgData name="Lines, Todd" userId="afaf7c3a-e8aa-4568-882a-02ad8f9e19b0" providerId="ADAL" clId="{298A166D-7D97-431D-8FAB-198A4D7160F4}" dt="2021-05-10T15:40:54.202" v="46" actId="1036"/>
-      <pc:docMkLst>
-        <pc:docMk/>
-      </pc:docMkLst>
-      <pc:sldChg chg="addSp delSp modSp mod">
-        <pc:chgData name="Lines, Todd" userId="afaf7c3a-e8aa-4568-882a-02ad8f9e19b0" providerId="ADAL" clId="{298A166D-7D97-431D-8FAB-198A4D7160F4}" dt="2021-05-10T15:39:50.655" v="21" actId="1036"/>
-        <pc:sldMkLst>
-          <pc:docMk/>
-          <pc:sldMk cId="0" sldId="269"/>
-        </pc:sldMkLst>
-      </pc:sldChg>
-      <pc:sldChg chg="addSp delSp modSp mod">
-        <pc:chgData name="Lines, Todd" userId="afaf7c3a-e8aa-4568-882a-02ad8f9e19b0" providerId="ADAL" clId="{298A166D-7D97-431D-8FAB-198A4D7160F4}" dt="2021-05-10T15:40:54.202" v="46" actId="1036"/>
-        <pc:sldMkLst>
-          <pc:docMk/>
-          <pc:sldMk cId="0" sldId="270"/>
-        </pc:sldMkLst>
+        <pc:spChg chg="mod">
+          <ac:chgData name="Lines, Todd" userId="afaf7c3a-e8aa-4568-882a-02ad8f9e19b0" providerId="ADAL" clId="{5FF5AC1B-ABA9-43D7-A1E3-2D92732CD6E2}" dt="2026-05-05T16:26:47.900" v="2" actId="20577"/>
+          <ac:spMkLst>
+            <pc:docMk/>
+            <pc:sldMk cId="1222242176" sldId="314"/>
+            <ac:spMk id="38944" creationId="{00000000-0000-0000-0000-000000000000}"/>
+          </ac:spMkLst>
+        </pc:spChg>
+        <pc:picChg chg="del mod">
+          <ac:chgData name="Lines, Todd" userId="afaf7c3a-e8aa-4568-882a-02ad8f9e19b0" providerId="ADAL" clId="{5FF5AC1B-ABA9-43D7-A1E3-2D92732CD6E2}" dt="2026-05-05T16:27:02.472" v="4" actId="21"/>
+          <ac:picMkLst>
+            <pc:docMk/>
+            <pc:sldMk cId="1222242176" sldId="314"/>
+            <ac:picMk id="7" creationId="{7F407937-B2EF-E280-9C27-2C220764F7F5}"/>
+          </ac:picMkLst>
+        </pc:picChg>
       </pc:sldChg>
     </pc:docChg>
   </pc:docChgLst>
@@ -616,7 +270,7 @@
           <a:p>
             <a:fld id="{DDC20DDF-410A-4A2E-BE2B-BF9258AB4EBC}" type="datetimeFigureOut">
               <a:rPr lang="en-US" smtClean="0"/>
-              <a:t>5/7/2025</a:t>
+              <a:t>5/5/2026</a:t>
             </a:fld>
             <a:endParaRPr lang="en-US"/>
           </a:p>
@@ -1177,7 +831,7 @@
             <a:fld id="{770D32CF-726D-406C-8E04-892C32375105}" type="datetimeFigureOut">
               <a:rPr lang="en-US" smtClean="0"/>
               <a:pPr/>
-              <a:t>5/7/2025</a:t>
+              <a:t>5/5/2026</a:t>
             </a:fld>
             <a:endParaRPr lang="en-US"/>
           </a:p>
@@ -1342,7 +996,7 @@
             <a:fld id="{770D32CF-726D-406C-8E04-892C32375105}" type="datetimeFigureOut">
               <a:rPr lang="en-US" smtClean="0"/>
               <a:pPr/>
-              <a:t>5/7/2025</a:t>
+              <a:t>5/5/2026</a:t>
             </a:fld>
             <a:endParaRPr lang="en-US"/>
           </a:p>
@@ -1517,7 +1171,7 @@
             <a:fld id="{770D32CF-726D-406C-8E04-892C32375105}" type="datetimeFigureOut">
               <a:rPr lang="en-US" smtClean="0"/>
               <a:pPr/>
-              <a:t>5/7/2025</a:t>
+              <a:t>5/5/2026</a:t>
             </a:fld>
             <a:endParaRPr lang="en-US"/>
           </a:p>
@@ -1682,7 +1336,7 @@
             <a:fld id="{770D32CF-726D-406C-8E04-892C32375105}" type="datetimeFigureOut">
               <a:rPr lang="en-US" smtClean="0"/>
               <a:pPr/>
-              <a:t>5/7/2025</a:t>
+              <a:t>5/5/2026</a:t>
             </a:fld>
             <a:endParaRPr lang="en-US"/>
           </a:p>
@@ -1924,7 +1578,7 @@
             <a:fld id="{770D32CF-726D-406C-8E04-892C32375105}" type="datetimeFigureOut">
               <a:rPr lang="en-US" smtClean="0"/>
               <a:pPr/>
-              <a:t>5/7/2025</a:t>
+              <a:t>5/5/2026</a:t>
             </a:fld>
             <a:endParaRPr lang="en-US"/>
           </a:p>
@@ -2206,7 +1860,7 @@
             <a:fld id="{770D32CF-726D-406C-8E04-892C32375105}" type="datetimeFigureOut">
               <a:rPr lang="en-US" smtClean="0"/>
               <a:pPr/>
-              <a:t>5/7/2025</a:t>
+              <a:t>5/5/2026</a:t>
             </a:fld>
             <a:endParaRPr lang="en-US"/>
           </a:p>
@@ -2622,7 +2276,7 @@
             <a:fld id="{770D32CF-726D-406C-8E04-892C32375105}" type="datetimeFigureOut">
               <a:rPr lang="en-US" smtClean="0"/>
               <a:pPr/>
-              <a:t>5/7/2025</a:t>
+              <a:t>5/5/2026</a:t>
             </a:fld>
             <a:endParaRPr lang="en-US"/>
           </a:p>
@@ -2736,7 +2390,7 @@
             <a:fld id="{770D32CF-726D-406C-8E04-892C32375105}" type="datetimeFigureOut">
               <a:rPr lang="en-US" smtClean="0"/>
               <a:pPr/>
-              <a:t>5/7/2025</a:t>
+              <a:t>5/5/2026</a:t>
             </a:fld>
             <a:endParaRPr lang="en-US"/>
           </a:p>
@@ -2828,7 +2482,7 @@
             <a:fld id="{770D32CF-726D-406C-8E04-892C32375105}" type="datetimeFigureOut">
               <a:rPr lang="en-US" smtClean="0"/>
               <a:pPr/>
-              <a:t>5/7/2025</a:t>
+              <a:t>5/5/2026</a:t>
             </a:fld>
             <a:endParaRPr lang="en-US"/>
           </a:p>
@@ -3100,7 +2754,7 @@
             <a:fld id="{770D32CF-726D-406C-8E04-892C32375105}" type="datetimeFigureOut">
               <a:rPr lang="en-US" smtClean="0"/>
               <a:pPr/>
-              <a:t>5/7/2025</a:t>
+              <a:t>5/5/2026</a:t>
             </a:fld>
             <a:endParaRPr lang="en-US"/>
           </a:p>
@@ -3349,7 +3003,7 @@
             <a:fld id="{770D32CF-726D-406C-8E04-892C32375105}" type="datetimeFigureOut">
               <a:rPr lang="en-US" smtClean="0"/>
               <a:pPr/>
-              <a:t>5/7/2025</a:t>
+              <a:t>5/5/2026</a:t>
             </a:fld>
             <a:endParaRPr lang="en-US"/>
           </a:p>
@@ -3557,7 +3211,7 @@
             <a:fld id="{770D32CF-726D-406C-8E04-892C32375105}" type="datetimeFigureOut">
               <a:rPr lang="en-US" smtClean="0"/>
               <a:pPr/>
-              <a:t>5/7/2025</a:t>
+              <a:t>5/5/2026</a:t>
             </a:fld>
             <a:endParaRPr lang="en-US"/>
           </a:p>
@@ -6807,7 +6461,7 @@
               </a:lnSpc>
             </a:pPr>
             <a:r>
-              <a:rPr lang="en-US" sz="2800"/>
+              <a:rPr lang="en-US" sz="2800" dirty="0"/>
               <a:t>Remember Inertial Reference Frames</a:t>
             </a:r>
           </a:p>
@@ -6818,7 +6472,7 @@
               </a:lnSpc>
             </a:pPr>
             <a:r>
-              <a:rPr lang="en-US" sz="2400"/>
+              <a:rPr lang="en-US" sz="2400" dirty="0"/>
               <a:t>The two observers can both take the view that they are stationary</a:t>
             </a:r>
           </a:p>
@@ -6829,7 +6483,7 @@
               </a:lnSpc>
             </a:pPr>
             <a:r>
-              <a:rPr lang="en-US" sz="2400"/>
+              <a:rPr lang="en-US" sz="2400" dirty="0"/>
               <a:t>Newton’s laws are all good in either frame</a:t>
             </a:r>
           </a:p>
@@ -7162,7 +6816,7 @@
               <p:spPr bwMode="auto">
                 <a:xfrm>
                   <a:off x="3182" y="2409"/>
-                  <a:ext cx="236" cy="231"/>
+                  <a:ext cx="290" cy="233"/>
                 </a:xfrm>
                 <a:prstGeom prst="rect">
                   <a:avLst/>
@@ -7182,7 +6836,7 @@
                 <a:lstStyle/>
                 <a:p>
                   <a:r>
-                    <a:rPr lang="en-US">
+                    <a:rPr lang="en-US" dirty="0" err="1">
                       <a:solidFill>
                         <a:srgbClr val="FF0000"/>
                       </a:solidFill>
@@ -7190,13 +6844,18 @@
                     <a:t>v</a:t>
                   </a:r>
                   <a:r>
-                    <a:rPr lang="en-US" baseline="-25000">
+                    <a:rPr lang="en-US" baseline="-25000" dirty="0" err="1">
                       <a:solidFill>
                         <a:srgbClr val="FF0000"/>
                       </a:solidFill>
                     </a:rPr>
-                    <a:t>x</a:t>
+                    <a:t>BA</a:t>
                   </a:r>
+                  <a:endParaRPr lang="en-US" baseline="-25000" dirty="0">
+                    <a:solidFill>
+                      <a:srgbClr val="FF0000"/>
+                    </a:solidFill>
+                  </a:endParaRPr>
                 </a:p>
               </p:txBody>
             </p:sp>

</xml_diff>